<commit_message>
commit marekting material update
</commit_message>
<xml_diff>
--- a/docs/marketing/Introducing Turas to clients.pptx
+++ b/docs/marketing/Introducing Turas to clients.pptx
@@ -13471,8 +13471,8 @@
         </p:nvSpPr>
         <p:spPr>
           <a:xfrm>
-            <a:off x="838200" y="3556000"/>
-            <a:ext cx="4495800" cy="2286000"/>
+            <a:off x="838200" y="3602300"/>
+            <a:ext cx="4495800" cy="1600200"/>
           </a:xfrm>
           <a:prstGeom prst="rect">
             <a:avLst/>
@@ -13539,6 +13539,19 @@
               <a:t>  Filed away, rarely revisited</a:t>
             </a:r>
           </a:p>
+          <a:p>
+            <a:pPr algn="l">
+              <a:spcBef>
+                <a:spcPts val="600"/>
+              </a:spcBef>
+            </a:pPr>
+            <a:endParaRPr lang="en-GB" sz="1400" dirty="0">
+              <a:solidFill>
+                <a:srgbClr val="9090A8"/>
+              </a:solidFill>
+              <a:latin typeface="Source Sans Pro"/>
+            </a:endParaRPr>
+          </a:p>
         </p:txBody>
       </p:sp>
       <p:sp>
@@ -13615,24 +13628,6 @@
                 <a:latin typeface="Source Sans Pro"/>
               </a:rPr>
               <a:t>  Build &amp; present a narrative without leaving the report</a:t>
-            </a:r>
-          </a:p>
-          <a:p>
-            <a:pPr algn="l">
-              <a:spcBef>
-                <a:spcPts val="200"/>
-              </a:spcBef>
-              <a:buFont typeface="Arial"/>
-              <a:buChar char="✓"/>
-            </a:pPr>
-            <a:r>
-              <a:rPr lang="en-GB" sz="1400" dirty="0">
-                <a:solidFill>
-                  <a:srgbClr val="323367"/>
-                </a:solidFill>
-                <a:latin typeface="Source Sans Pro"/>
-              </a:rPr>
-              <a:t>  Advanced analysis and more in the same file</a:t>
             </a:r>
           </a:p>
         </p:txBody>

</xml_diff>